<commit_message>
Refine editorial row alignment with native anchors and reviewed comparisons
</commit_message>
<xml_diff>
--- a/catalog/editorial/samples/representative.pptx
+++ b/catalog/editorial/samples/representative.pptx
@@ -1102,12 +1102,17 @@
           </a:p>
           <a:p>
             <a:r>
+              <a:t>  "row_alignments": {},</a:t>
+            </a:r>
+          </a:p>
+          <a:p>
+            <a:r>
               <a:t>  "images": {},</a:t>
             </a:r>
           </a:p>
           <a:p>
             <a:r>
-              <a:t>  "template_sha256": "373871de87754b38c8f1fed072a644fd9d624823fd0ac5a4753f6e04247dd2ff"</a:t>
+              <a:t>  "template_sha256": "ff0a4781bb1465467ac9ed96880843f7e2b10f8c90722b4befbca4838a610a1b"</a:t>
             </a:r>
           </a:p>
           <a:p>
@@ -1952,12 +1957,17 @@
           </a:p>
           <a:p>
             <a:r>
+              <a:t>  "row_alignments": {},</a:t>
+            </a:r>
+          </a:p>
+          <a:p>
+            <a:r>
               <a:t>  "images": {},</a:t>
             </a:r>
           </a:p>
           <a:p>
             <a:r>
-              <a:t>  "template_sha256": "8eaf948781dead9554a62e3ac491faba9cb93dc833fd60ddb4615a3e302e4e72"</a:t>
+              <a:t>  "template_sha256": "5abf4bc00f09927d248be6792b2823517de33cd34c4cabba7b54cbc5ae122823"</a:t>
             </a:r>
           </a:p>
           <a:p>
@@ -3022,12 +3032,17 @@
           </a:p>
           <a:p>
             <a:r>
+              <a:t>  "row_alignments": {},</a:t>
+            </a:r>
+          </a:p>
+          <a:p>
+            <a:r>
               <a:t>  "images": {},</a:t>
             </a:r>
           </a:p>
           <a:p>
             <a:r>
-              <a:t>  "template_sha256": "f23fbba0be512b40285904d25dfa2e0f7155bbb5e7d7a4a059e6fdff5e255115"</a:t>
+              <a:t>  "template_sha256": "6b143d7815acfd4ae1cbf24a7c95d46d64b789567061c6ba384bff91be84f4db"</a:t>
             </a:r>
           </a:p>
           <a:p>
@@ -3872,12 +3887,17 @@
           </a:p>
           <a:p>
             <a:r>
+              <a:t>  "row_alignments": {},</a:t>
+            </a:r>
+          </a:p>
+          <a:p>
+            <a:r>
               <a:t>  "images": {},</a:t>
             </a:r>
           </a:p>
           <a:p>
             <a:r>
-              <a:t>  "template_sha256": "2ccc092dd4d266ecd52c6b8c696f7cc8ac054b0c1a8052bb9f97478f45783701"</a:t>
+              <a:t>  "template_sha256": "0c41da28128ae83e7fde7ca4a014839433c96eafe40ab7809cafb8d7a9e74c33"</a:t>
             </a:r>
           </a:p>
           <a:p>
@@ -4592,12 +4612,17 @@
           </a:p>
           <a:p>
             <a:r>
+              <a:t>  "row_alignments": {},</a:t>
+            </a:r>
+          </a:p>
+          <a:p>
+            <a:r>
               <a:t>  "images": {},</a:t>
             </a:r>
           </a:p>
           <a:p>
             <a:r>
-              <a:t>  "template_sha256": "d84dc9a9af4e114daf074a82c3dc7112852bcfcf402cd8851b2a5427b4d56685"</a:t>
+              <a:t>  "template_sha256": "2bc7cd165bc5384dd2c1271100088da12a7ad76866cd16b07bf48b219f176c6a"</a:t>
             </a:r>
           </a:p>
           <a:p>
@@ -5762,12 +5787,17 @@
           </a:p>
           <a:p>
             <a:r>
+              <a:t>  "row_alignments": {},</a:t>
+            </a:r>
+          </a:p>
+          <a:p>
+            <a:r>
               <a:t>  "images": {},</a:t>
             </a:r>
           </a:p>
           <a:p>
             <a:r>
-              <a:t>  "template_sha256": "9815c7ffea958d535e3532b69a0d70e7b5d6acdeeae91964f3820387b4085d4d"</a:t>
+              <a:t>  "template_sha256": "b21da0482646304af7dae48ef6912a9b6762dc78ed5b7f5e2338eec82a777432"</a:t>
             </a:r>
           </a:p>
           <a:p>
@@ -6632,12 +6662,17 @@
           </a:p>
           <a:p>
             <a:r>
+              <a:t>  "row_alignments": {},</a:t>
+            </a:r>
+          </a:p>
+          <a:p>
+            <a:r>
               <a:t>  "images": {},</a:t>
             </a:r>
           </a:p>
           <a:p>
             <a:r>
-              <a:t>  "template_sha256": "d8eaf48fd337606e0f3273466c70eed3b35c566b145360ca90f7e1a2dfdcb5b2"</a:t>
+              <a:t>  "template_sha256": "65f204abf42709de2c84415cfd8743b0a5fbfaa9796c8e9fb1be0c73a80b75d6"</a:t>
             </a:r>
           </a:p>
           <a:p>
@@ -7352,12 +7387,17 @@
           </a:p>
           <a:p>
             <a:r>
+              <a:t>  "row_alignments": {},</a:t>
+            </a:r>
+          </a:p>
+          <a:p>
+            <a:r>
               <a:t>  "images": {},</a:t>
             </a:r>
           </a:p>
           <a:p>
             <a:r>
-              <a:t>  "template_sha256": "77c63ee2a3ab4725dbf3d01e3e94ffe3dcad2657c1ba94d285d2189ff8dd60bf"</a:t>
+              <a:t>  "template_sha256": "3362bf7b84251cab394baf7c635d3be6ef0c384b817c7e65131f2d432bf7629b"</a:t>
             </a:r>
           </a:p>
           <a:p>
@@ -8072,12 +8112,17 @@
           </a:p>
           <a:p>
             <a:r>
+              <a:t>  "row_alignments": {},</a:t>
+            </a:r>
+          </a:p>
+          <a:p>
+            <a:r>
               <a:t>  "images": {},</a:t>
             </a:r>
           </a:p>
           <a:p>
             <a:r>
-              <a:t>  "template_sha256": "7e9dcbe298d4fb56e704e6dca81e0c14499f59e3d69ba3aa08d99878a6adbc46"</a:t>
+              <a:t>  "template_sha256": "9b5159b29c396839d3c62e06fbac24a9f5756f7abbad9fdbafcd528824d75056"</a:t>
             </a:r>
           </a:p>
           <a:p>
@@ -8792,12 +8837,17 @@
           </a:p>
           <a:p>
             <a:r>
+              <a:t>  "row_alignments": {},</a:t>
+            </a:r>
+          </a:p>
+          <a:p>
+            <a:r>
               <a:t>  "images": {},</a:t>
             </a:r>
           </a:p>
           <a:p>
             <a:r>
-              <a:t>  "template_sha256": "3529bb9757b1f2a155c8665df1f90558fdfb1436345aa5aead4ef9c7e94676f0"</a:t>
+              <a:t>  "template_sha256": "b78fc81f26ab302c659c4dde409ca4f5fce394986bbbf80ba45edd631f1f8f40"</a:t>
             </a:r>
           </a:p>
           <a:p>
@@ -9562,12 +9612,17 @@
           </a:p>
           <a:p>
             <a:r>
+              <a:t>  "row_alignments": {},</a:t>
+            </a:r>
+          </a:p>
+          <a:p>
+            <a:r>
               <a:t>  "images": {},</a:t>
             </a:r>
           </a:p>
           <a:p>
             <a:r>
-              <a:t>  "template_sha256": "1ad1774e3f1fe7f2ea2c7dd8715dbda8108d91d1525b2eb53c86bcfed6113fa1"</a:t>
+              <a:t>  "template_sha256": "5b593446be0d0769f4a209d89011e58496fe0543c2ae3231d84ba3422c0d9b64"</a:t>
             </a:r>
           </a:p>
           <a:p>
@@ -10132,12 +10187,17 @@
           </a:p>
           <a:p>
             <a:r>
+              <a:t>  "row_alignments": {},</a:t>
+            </a:r>
+          </a:p>
+          <a:p>
+            <a:r>
               <a:t>  "images": {},</a:t>
             </a:r>
           </a:p>
           <a:p>
             <a:r>
-              <a:t>  "template_sha256": "ddc84184daa57b92e8c261ec15c249357a5a3562efbab540d3117044ec4c45cb"</a:t>
+              <a:t>  "template_sha256": "fa74574b11b6ce3b744ad424b83b9bd1f1932ff121bcd3f039c22200dc59bba4"</a:t>
             </a:r>
           </a:p>
           <a:p>
@@ -13217,7 +13277,7 @@
           <a:noFill/>
         </p:spPr>
         <p:txBody>
-          <a:bodyPr wrap="square" lIns="18288" rIns="18288" tIns="13716" bIns="13716">
+          <a:bodyPr wrap="square" anchor="t" lIns="18288" rIns="18288" tIns="13716" bIns="13716">
             <a:noAutofit/>
           </a:bodyPr>
           <a:lstStyle/>
@@ -13272,7 +13332,7 @@
           <a:noFill/>
         </p:spPr>
         <p:txBody>
-          <a:bodyPr wrap="square" lIns="18288" rIns="18288" tIns="13716" bIns="13716">
+          <a:bodyPr wrap="square" anchor="t" lIns="18288" rIns="18288" tIns="13716" bIns="13716">
             <a:noAutofit/>
           </a:bodyPr>
           <a:lstStyle/>
@@ -13327,7 +13387,7 @@
           <a:noFill/>
         </p:spPr>
         <p:txBody>
-          <a:bodyPr wrap="square" lIns="18288" rIns="18288" tIns="13716" bIns="13716">
+          <a:bodyPr wrap="square" anchor="t" lIns="18288" rIns="18288" tIns="13716" bIns="13716">
             <a:noAutofit/>
           </a:bodyPr>
           <a:lstStyle/>
@@ -13426,7 +13486,7 @@
           <a:noFill/>
         </p:spPr>
         <p:txBody>
-          <a:bodyPr wrap="square" lIns="18288" rIns="18288" tIns="13716" bIns="13716">
+          <a:bodyPr wrap="square" anchor="t" lIns="18288" rIns="18288" tIns="13716" bIns="13716">
             <a:noAutofit/>
           </a:bodyPr>
           <a:lstStyle/>
@@ -13481,7 +13541,7 @@
           <a:noFill/>
         </p:spPr>
         <p:txBody>
-          <a:bodyPr wrap="square" lIns="18288" rIns="18288" tIns="13716" bIns="13716">
+          <a:bodyPr wrap="square" anchor="t" lIns="18288" rIns="18288" tIns="13716" bIns="13716">
             <a:noAutofit/>
           </a:bodyPr>
           <a:lstStyle/>
@@ -13626,7 +13686,7 @@
           <a:noFill/>
         </p:spPr>
         <p:txBody>
-          <a:bodyPr wrap="square" lIns="18288" rIns="18288" tIns="13716" bIns="13716">
+          <a:bodyPr wrap="square" anchor="t" lIns="18288" rIns="18288" tIns="13716" bIns="13716">
             <a:noAutofit/>
           </a:bodyPr>
           <a:lstStyle/>
@@ -13681,7 +13741,7 @@
           <a:noFill/>
         </p:spPr>
         <p:txBody>
-          <a:bodyPr wrap="square" lIns="18288" rIns="18288" tIns="13716" bIns="13716">
+          <a:bodyPr wrap="square" anchor="t" lIns="18288" rIns="18288" tIns="13716" bIns="13716">
             <a:noAutofit/>
           </a:bodyPr>
           <a:lstStyle/>
@@ -13826,7 +13886,7 @@
           <a:noFill/>
         </p:spPr>
         <p:txBody>
-          <a:bodyPr wrap="square" lIns="18288" rIns="18288" tIns="13716" bIns="13716">
+          <a:bodyPr wrap="square" anchor="t" lIns="18288" rIns="18288" tIns="13716" bIns="13716">
             <a:noAutofit/>
           </a:bodyPr>
           <a:lstStyle/>
@@ -13881,7 +13941,7 @@
           <a:noFill/>
         </p:spPr>
         <p:txBody>
-          <a:bodyPr wrap="square" lIns="18288" rIns="18288" tIns="13716" bIns="13716">
+          <a:bodyPr wrap="square" anchor="t" lIns="18288" rIns="18288" tIns="13716" bIns="13716">
             <a:noAutofit/>
           </a:bodyPr>
           <a:lstStyle/>
@@ -14006,7 +14066,7 @@
           <a:noFill/>
         </p:spPr>
         <p:txBody>
-          <a:bodyPr wrap="square" lIns="18288" rIns="18288" tIns="13716" bIns="13716">
+          <a:bodyPr wrap="square" anchor="t" lIns="18288" rIns="18288" tIns="13716" bIns="13716">
             <a:noAutofit/>
           </a:bodyPr>
           <a:lstStyle/>
@@ -14061,7 +14121,7 @@
           <a:noFill/>
         </p:spPr>
         <p:txBody>
-          <a:bodyPr wrap="square" lIns="18288" rIns="18288" tIns="13716" bIns="13716">
+          <a:bodyPr wrap="square" anchor="t" lIns="18288" rIns="18288" tIns="13716" bIns="13716">
             <a:noAutofit/>
           </a:bodyPr>
           <a:lstStyle/>
@@ -14116,7 +14176,7 @@
           <a:noFill/>
         </p:spPr>
         <p:txBody>
-          <a:bodyPr wrap="square" lIns="18288" rIns="18288" tIns="13716" bIns="13716">
+          <a:bodyPr wrap="square" anchor="t" lIns="18288" rIns="18288" tIns="13716" bIns="13716">
             <a:noAutofit/>
           </a:bodyPr>
           <a:lstStyle/>
@@ -14215,7 +14275,7 @@
           <a:noFill/>
         </p:spPr>
         <p:txBody>
-          <a:bodyPr wrap="square" lIns="18288" rIns="18288" tIns="13716" bIns="13716">
+          <a:bodyPr wrap="square" anchor="t" lIns="18288" rIns="18288" tIns="13716" bIns="13716">
             <a:noAutofit/>
           </a:bodyPr>
           <a:lstStyle/>
@@ -14270,7 +14330,7 @@
           <a:noFill/>
         </p:spPr>
         <p:txBody>
-          <a:bodyPr wrap="square" lIns="18288" rIns="18288" tIns="13716" bIns="13716">
+          <a:bodyPr wrap="square" anchor="t" lIns="18288" rIns="18288" tIns="13716" bIns="13716">
             <a:noAutofit/>
           </a:bodyPr>
           <a:lstStyle/>
@@ -14369,7 +14429,7 @@
           <a:noFill/>
         </p:spPr>
         <p:txBody>
-          <a:bodyPr wrap="square" lIns="18288" rIns="18288" tIns="13716" bIns="13716">
+          <a:bodyPr wrap="square" anchor="t" lIns="18288" rIns="18288" tIns="13716" bIns="13716">
             <a:noAutofit/>
           </a:bodyPr>
           <a:lstStyle/>
@@ -14424,7 +14484,7 @@
           <a:noFill/>
         </p:spPr>
         <p:txBody>
-          <a:bodyPr wrap="square" lIns="18288" rIns="18288" tIns="13716" bIns="13716">
+          <a:bodyPr wrap="square" anchor="t" lIns="18288" rIns="18288" tIns="13716" bIns="13716">
             <a:noAutofit/>
           </a:bodyPr>
           <a:lstStyle/>
@@ -14479,7 +14539,7 @@
           <a:noFill/>
         </p:spPr>
         <p:txBody>
-          <a:bodyPr wrap="square" lIns="18288" rIns="18288" tIns="13716" bIns="13716">
+          <a:bodyPr wrap="square" anchor="t" lIns="18288" rIns="18288" tIns="13716" bIns="13716">
             <a:noAutofit/>
           </a:bodyPr>
           <a:lstStyle/>
@@ -14580,7 +14640,7 @@
           <a:noFill/>
         </p:spPr>
         <p:txBody>
-          <a:bodyPr wrap="square" lIns="18288" rIns="18288" tIns="13716" bIns="13716">
+          <a:bodyPr wrap="square" anchor="t" lIns="18288" rIns="18288" tIns="13716" bIns="13716">
             <a:noAutofit/>
           </a:bodyPr>
           <a:lstStyle/>
@@ -14635,7 +14695,7 @@
           <a:noFill/>
         </p:spPr>
         <p:txBody>
-          <a:bodyPr wrap="square" lIns="18288" rIns="18288" tIns="13716" bIns="13716">
+          <a:bodyPr wrap="square" anchor="t" lIns="18288" rIns="18288" tIns="13716" bIns="13716">
             <a:noAutofit/>
           </a:bodyPr>
           <a:lstStyle/>
@@ -14690,7 +14750,7 @@
           <a:noFill/>
         </p:spPr>
         <p:txBody>
-          <a:bodyPr wrap="square" lIns="18288" rIns="18288" tIns="13716" bIns="13716">
+          <a:bodyPr wrap="square" anchor="t" lIns="18288" rIns="18288" tIns="13716" bIns="13716">
             <a:noAutofit/>
           </a:bodyPr>
           <a:lstStyle/>
@@ -14791,7 +14851,7 @@
           <a:noFill/>
         </p:spPr>
         <p:txBody>
-          <a:bodyPr wrap="square" lIns="18288" rIns="18288" tIns="13716" bIns="13716">
+          <a:bodyPr wrap="square" anchor="t" lIns="18288" rIns="18288" tIns="13716" bIns="13716">
             <a:noAutofit/>
           </a:bodyPr>
           <a:lstStyle/>
@@ -14846,7 +14906,7 @@
           <a:noFill/>
         </p:spPr>
         <p:txBody>
-          <a:bodyPr wrap="square" lIns="18288" rIns="18288" tIns="13716" bIns="13716">
+          <a:bodyPr wrap="square" anchor="t" lIns="18288" rIns="18288" tIns="13716" bIns="13716">
             <a:noAutofit/>
           </a:bodyPr>
           <a:lstStyle/>
@@ -14901,7 +14961,7 @@
           <a:noFill/>
         </p:spPr>
         <p:txBody>
-          <a:bodyPr wrap="square" lIns="18288" rIns="18288" tIns="13716" bIns="13716">
+          <a:bodyPr wrap="square" anchor="t" lIns="18288" rIns="18288" tIns="13716" bIns="13716">
             <a:noAutofit/>
           </a:bodyPr>
           <a:lstStyle/>
@@ -15002,7 +15062,7 @@
           <a:noFill/>
         </p:spPr>
         <p:txBody>
-          <a:bodyPr wrap="square" lIns="18288" rIns="18288" tIns="13716" bIns="13716">
+          <a:bodyPr wrap="square" anchor="t" lIns="18288" rIns="18288" tIns="13716" bIns="13716">
             <a:noAutofit/>
           </a:bodyPr>
           <a:lstStyle/>
@@ -15057,7 +15117,7 @@
           <a:noFill/>
         </p:spPr>
         <p:txBody>
-          <a:bodyPr wrap="square" lIns="18288" rIns="18288" tIns="13716" bIns="13716">
+          <a:bodyPr wrap="square" anchor="t" lIns="18288" rIns="18288" tIns="13716" bIns="13716">
             <a:noAutofit/>
           </a:bodyPr>
           <a:lstStyle/>
@@ -15112,7 +15172,7 @@
           <a:noFill/>
         </p:spPr>
         <p:txBody>
-          <a:bodyPr wrap="square" lIns="18288" rIns="18288" tIns="13716" bIns="13716">
+          <a:bodyPr wrap="square" anchor="t" lIns="18288" rIns="18288" tIns="13716" bIns="13716">
             <a:noAutofit/>
           </a:bodyPr>
           <a:lstStyle/>
@@ -15237,7 +15297,7 @@
           <a:noFill/>
         </p:spPr>
         <p:txBody>
-          <a:bodyPr wrap="square" lIns="18288" rIns="18288" tIns="13716" bIns="13716">
+          <a:bodyPr wrap="square" anchor="t" lIns="18288" rIns="18288" tIns="13716" bIns="13716">
             <a:noAutofit/>
           </a:bodyPr>
           <a:lstStyle/>
@@ -15292,7 +15352,7 @@
           <a:noFill/>
         </p:spPr>
         <p:txBody>
-          <a:bodyPr wrap="square" lIns="18288" rIns="18288" tIns="13716" bIns="13716">
+          <a:bodyPr wrap="square" anchor="t" lIns="18288" rIns="18288" tIns="13716" bIns="13716">
             <a:noAutofit/>
           </a:bodyPr>
           <a:lstStyle/>
@@ -15347,7 +15407,7 @@
           <a:noFill/>
         </p:spPr>
         <p:txBody>
-          <a:bodyPr wrap="square" lIns="18288" rIns="18288" tIns="13716" bIns="13716">
+          <a:bodyPr wrap="square" anchor="t" lIns="18288" rIns="18288" tIns="13716" bIns="13716">
             <a:noAutofit/>
           </a:bodyPr>
           <a:lstStyle/>
@@ -15446,7 +15506,7 @@
           <a:noFill/>
         </p:spPr>
         <p:txBody>
-          <a:bodyPr wrap="square" lIns="18288" rIns="18288" tIns="13716" bIns="13716">
+          <a:bodyPr wrap="square" anchor="t" lIns="18288" rIns="18288" tIns="13716" bIns="13716">
             <a:noAutofit/>
           </a:bodyPr>
           <a:lstStyle/>
@@ -15501,7 +15561,7 @@
           <a:noFill/>
         </p:spPr>
         <p:txBody>
-          <a:bodyPr wrap="square" lIns="18288" rIns="18288" tIns="13716" bIns="13716">
+          <a:bodyPr wrap="square" anchor="t" lIns="18288" rIns="18288" tIns="13716" bIns="13716">
             <a:noAutofit/>
           </a:bodyPr>
           <a:lstStyle/>
@@ -15565,7 +15625,7 @@
               <a:tr h="713232">
                 <a:tc>
                   <a:txBody>
-                    <a:bodyPr wrap="square" lIns="18288" rIns="18288" tIns="13716" bIns="13716">
+                    <a:bodyPr wrap="square" anchor="t" lIns="18288" rIns="18288" tIns="13716" bIns="13716">
                       <a:noAutofit/>
                     </a:bodyPr>
                     <a:lstStyle/>
@@ -15602,7 +15662,7 @@
                       </a:r>
                     </a:p>
                   </a:txBody>
-                  <a:tcPr marL="155448" marR="155448" marT="64008" marB="64008">
+                  <a:tcPr marL="155448" marR="155448" marT="64008" marB="64008" anchor="ctr">
                     <a:solidFill>
                       <a:srgbClr val="213547"/>
                     </a:solidFill>
@@ -15610,7 +15670,7 @@
                 </a:tc>
                 <a:tc>
                   <a:txBody>
-                    <a:bodyPr wrap="square" lIns="18288" rIns="18288" tIns="13716" bIns="13716">
+                    <a:bodyPr wrap="square" anchor="t" lIns="18288" rIns="18288" tIns="13716" bIns="13716">
                       <a:noAutofit/>
                     </a:bodyPr>
                     <a:lstStyle/>
@@ -15647,7 +15707,7 @@
                       </a:r>
                     </a:p>
                   </a:txBody>
-                  <a:tcPr marL="155448" marR="155448" marT="64008" marB="64008">
+                  <a:tcPr marL="155448" marR="155448" marT="64008" marB="64008" anchor="ctr">
                     <a:solidFill>
                       <a:srgbClr val="213547"/>
                     </a:solidFill>
@@ -15655,7 +15715,7 @@
                 </a:tc>
                 <a:tc>
                   <a:txBody>
-                    <a:bodyPr wrap="square" lIns="18288" rIns="18288" tIns="13716" bIns="13716">
+                    <a:bodyPr wrap="square" anchor="t" lIns="18288" rIns="18288" tIns="13716" bIns="13716">
                       <a:noAutofit/>
                     </a:bodyPr>
                     <a:lstStyle/>
@@ -15692,7 +15752,7 @@
                       </a:r>
                     </a:p>
                   </a:txBody>
-                  <a:tcPr marL="155448" marR="155448" marT="64008" marB="64008">
+                  <a:tcPr marL="155448" marR="155448" marT="64008" marB="64008" anchor="ctr">
                     <a:solidFill>
                       <a:srgbClr val="213547"/>
                     </a:solidFill>
@@ -15702,7 +15762,7 @@
               <a:tr h="713232">
                 <a:tc>
                   <a:txBody>
-                    <a:bodyPr wrap="square" lIns="18288" rIns="18288" tIns="13716" bIns="13716">
+                    <a:bodyPr wrap="square" anchor="t" lIns="18288" rIns="18288" tIns="13716" bIns="13716">
                       <a:noAutofit/>
                     </a:bodyPr>
                     <a:lstStyle/>
@@ -15739,7 +15799,7 @@
                       </a:r>
                     </a:p>
                   </a:txBody>
-                  <a:tcPr marL="155448" marR="155448" marT="64008" marB="64008">
+                  <a:tcPr marL="155448" marR="155448" marT="64008" marB="64008" anchor="ctr">
                     <a:solidFill>
                       <a:srgbClr val="FFFFFF"/>
                     </a:solidFill>
@@ -15747,7 +15807,7 @@
                 </a:tc>
                 <a:tc>
                   <a:txBody>
-                    <a:bodyPr wrap="square" lIns="18288" rIns="18288" tIns="13716" bIns="13716">
+                    <a:bodyPr wrap="square" anchor="t" lIns="18288" rIns="18288" tIns="13716" bIns="13716">
                       <a:noAutofit/>
                     </a:bodyPr>
                     <a:lstStyle/>
@@ -15784,7 +15844,7 @@
                       </a:r>
                     </a:p>
                   </a:txBody>
-                  <a:tcPr marL="155448" marR="155448" marT="64008" marB="64008">
+                  <a:tcPr marL="155448" marR="155448" marT="64008" marB="64008" anchor="ctr">
                     <a:solidFill>
                       <a:srgbClr val="FFFFFF"/>
                     </a:solidFill>
@@ -15792,7 +15852,7 @@
                 </a:tc>
                 <a:tc>
                   <a:txBody>
-                    <a:bodyPr wrap="square" lIns="18288" rIns="18288" tIns="13716" bIns="13716">
+                    <a:bodyPr wrap="square" anchor="t" lIns="18288" rIns="18288" tIns="13716" bIns="13716">
                       <a:noAutofit/>
                     </a:bodyPr>
                     <a:lstStyle/>
@@ -15861,7 +15921,7 @@
                       </a:r>
                     </a:p>
                   </a:txBody>
-                  <a:tcPr marL="155448" marR="155448" marT="64008" marB="64008">
+                  <a:tcPr marL="155448" marR="155448" marT="64008" marB="64008" anchor="ctr">
                     <a:solidFill>
                       <a:srgbClr val="FFFFFF"/>
                     </a:solidFill>
@@ -15871,7 +15931,7 @@
               <a:tr h="713232">
                 <a:tc>
                   <a:txBody>
-                    <a:bodyPr wrap="square" lIns="18288" rIns="18288" tIns="13716" bIns="13716">
+                    <a:bodyPr wrap="square" anchor="t" lIns="18288" rIns="18288" tIns="13716" bIns="13716">
                       <a:noAutofit/>
                     </a:bodyPr>
                     <a:lstStyle/>
@@ -15908,7 +15968,7 @@
                       </a:r>
                     </a:p>
                   </a:txBody>
-                  <a:tcPr marL="155448" marR="155448" marT="64008" marB="64008">
+                  <a:tcPr marL="155448" marR="155448" marT="64008" marB="64008" anchor="ctr">
                     <a:solidFill>
                       <a:srgbClr val="EDF1F4"/>
                     </a:solidFill>
@@ -15916,7 +15976,7 @@
                 </a:tc>
                 <a:tc>
                   <a:txBody>
-                    <a:bodyPr wrap="square" lIns="18288" rIns="18288" tIns="13716" bIns="13716">
+                    <a:bodyPr wrap="square" anchor="t" lIns="18288" rIns="18288" tIns="13716" bIns="13716">
                       <a:noAutofit/>
                     </a:bodyPr>
                     <a:lstStyle/>
@@ -15953,7 +16013,7 @@
                       </a:r>
                     </a:p>
                   </a:txBody>
-                  <a:tcPr marL="155448" marR="155448" marT="64008" marB="64008">
+                  <a:tcPr marL="155448" marR="155448" marT="64008" marB="64008" anchor="ctr">
                     <a:solidFill>
                       <a:srgbClr val="EDF1F4"/>
                     </a:solidFill>
@@ -15961,7 +16021,7 @@
                 </a:tc>
                 <a:tc>
                   <a:txBody>
-                    <a:bodyPr wrap="square" lIns="18288" rIns="18288" tIns="13716" bIns="13716">
+                    <a:bodyPr wrap="square" anchor="t" lIns="18288" rIns="18288" tIns="13716" bIns="13716">
                       <a:noAutofit/>
                     </a:bodyPr>
                     <a:lstStyle/>
@@ -16030,7 +16090,7 @@
                       </a:r>
                     </a:p>
                   </a:txBody>
-                  <a:tcPr marL="155448" marR="155448" marT="64008" marB="64008">
+                  <a:tcPr marL="155448" marR="155448" marT="64008" marB="64008" anchor="ctr">
                     <a:solidFill>
                       <a:srgbClr val="EDF1F4"/>
                     </a:solidFill>
@@ -16040,7 +16100,7 @@
               <a:tr h="713232">
                 <a:tc>
                   <a:txBody>
-                    <a:bodyPr wrap="square" lIns="18288" rIns="18288" tIns="13716" bIns="13716">
+                    <a:bodyPr wrap="square" anchor="t" lIns="18288" rIns="18288" tIns="13716" bIns="13716">
                       <a:noAutofit/>
                     </a:bodyPr>
                     <a:lstStyle/>
@@ -16077,7 +16137,7 @@
                       </a:r>
                     </a:p>
                   </a:txBody>
-                  <a:tcPr marL="155448" marR="155448" marT="64008" marB="64008">
+                  <a:tcPr marL="155448" marR="155448" marT="64008" marB="64008" anchor="ctr">
                     <a:solidFill>
                       <a:srgbClr val="FFFFFF"/>
                     </a:solidFill>
@@ -16085,7 +16145,7 @@
                 </a:tc>
                 <a:tc>
                   <a:txBody>
-                    <a:bodyPr wrap="square" lIns="18288" rIns="18288" tIns="13716" bIns="13716">
+                    <a:bodyPr wrap="square" anchor="t" lIns="18288" rIns="18288" tIns="13716" bIns="13716">
                       <a:noAutofit/>
                     </a:bodyPr>
                     <a:lstStyle/>
@@ -16122,7 +16182,7 @@
                       </a:r>
                     </a:p>
                   </a:txBody>
-                  <a:tcPr marL="155448" marR="155448" marT="64008" marB="64008">
+                  <a:tcPr marL="155448" marR="155448" marT="64008" marB="64008" anchor="ctr">
                     <a:solidFill>
                       <a:srgbClr val="FFFFFF"/>
                     </a:solidFill>
@@ -16130,7 +16190,7 @@
                 </a:tc>
                 <a:tc>
                   <a:txBody>
-                    <a:bodyPr wrap="square" lIns="18288" rIns="18288" tIns="13716" bIns="13716">
+                    <a:bodyPr wrap="square" anchor="t" lIns="18288" rIns="18288" tIns="13716" bIns="13716">
                       <a:noAutofit/>
                     </a:bodyPr>
                     <a:lstStyle/>
@@ -16199,7 +16259,7 @@
                       </a:r>
                     </a:p>
                   </a:txBody>
-                  <a:tcPr marL="155448" marR="155448" marT="64008" marB="64008">
+                  <a:tcPr marL="155448" marR="155448" marT="64008" marB="64008" anchor="ctr">
                     <a:solidFill>
                       <a:srgbClr val="FFFFFF"/>
                     </a:solidFill>
@@ -16209,7 +16269,7 @@
               <a:tr h="713232">
                 <a:tc>
                   <a:txBody>
-                    <a:bodyPr wrap="square" lIns="18288" rIns="18288" tIns="13716" bIns="13716">
+                    <a:bodyPr wrap="square" anchor="t" lIns="18288" rIns="18288" tIns="13716" bIns="13716">
                       <a:noAutofit/>
                     </a:bodyPr>
                     <a:lstStyle/>
@@ -16246,7 +16306,7 @@
                       </a:r>
                     </a:p>
                   </a:txBody>
-                  <a:tcPr marL="155448" marR="155448" marT="64008" marB="64008">
+                  <a:tcPr marL="155448" marR="155448" marT="64008" marB="64008" anchor="ctr">
                     <a:solidFill>
                       <a:srgbClr val="EDF1F4"/>
                     </a:solidFill>
@@ -16254,7 +16314,7 @@
                 </a:tc>
                 <a:tc>
                   <a:txBody>
-                    <a:bodyPr wrap="square" lIns="18288" rIns="18288" tIns="13716" bIns="13716">
+                    <a:bodyPr wrap="square" anchor="t" lIns="18288" rIns="18288" tIns="13716" bIns="13716">
                       <a:noAutofit/>
                     </a:bodyPr>
                     <a:lstStyle/>
@@ -16291,7 +16351,7 @@
                       </a:r>
                     </a:p>
                   </a:txBody>
-                  <a:tcPr marL="155448" marR="155448" marT="64008" marB="64008">
+                  <a:tcPr marL="155448" marR="155448" marT="64008" marB="64008" anchor="ctr">
                     <a:solidFill>
                       <a:srgbClr val="EDF1F4"/>
                     </a:solidFill>
@@ -16299,7 +16359,7 @@
                 </a:tc>
                 <a:tc>
                   <a:txBody>
-                    <a:bodyPr wrap="square" lIns="18288" rIns="18288" tIns="13716" bIns="13716">
+                    <a:bodyPr wrap="square" anchor="t" lIns="18288" rIns="18288" tIns="13716" bIns="13716">
                       <a:noAutofit/>
                     </a:bodyPr>
                     <a:lstStyle/>
@@ -16368,7 +16428,7 @@
                       </a:r>
                     </a:p>
                   </a:txBody>
-                  <a:tcPr marL="155448" marR="155448" marT="64008" marB="64008">
+                  <a:tcPr marL="155448" marR="155448" marT="64008" marB="64008" anchor="ctr">
                     <a:solidFill>
                       <a:srgbClr val="EDF1F4"/>
                     </a:solidFill>
@@ -16396,7 +16456,7 @@
           <a:noFill/>
         </p:spPr>
         <p:txBody>
-          <a:bodyPr wrap="square" lIns="18288" rIns="18288" tIns="13716" bIns="13716">
+          <a:bodyPr wrap="square" anchor="t" lIns="18288" rIns="18288" tIns="13716" bIns="13716">
             <a:noAutofit/>
           </a:bodyPr>
           <a:lstStyle/>
@@ -16521,7 +16581,7 @@
           <a:noFill/>
         </p:spPr>
         <p:txBody>
-          <a:bodyPr wrap="square" lIns="18288" rIns="18288" tIns="13716" bIns="13716">
+          <a:bodyPr wrap="square" anchor="t" lIns="18288" rIns="18288" tIns="13716" bIns="13716">
             <a:noAutofit/>
           </a:bodyPr>
           <a:lstStyle/>
@@ -16576,7 +16636,7 @@
           <a:noFill/>
         </p:spPr>
         <p:txBody>
-          <a:bodyPr wrap="square" lIns="18288" rIns="18288" tIns="13716" bIns="13716">
+          <a:bodyPr wrap="square" anchor="t" lIns="18288" rIns="18288" tIns="13716" bIns="13716">
             <a:noAutofit/>
           </a:bodyPr>
           <a:lstStyle/>
@@ -16631,7 +16691,7 @@
           <a:noFill/>
         </p:spPr>
         <p:txBody>
-          <a:bodyPr wrap="square" lIns="18288" rIns="18288" tIns="13716" bIns="13716">
+          <a:bodyPr wrap="square" anchor="t" lIns="18288" rIns="18288" tIns="13716" bIns="13716">
             <a:noAutofit/>
           </a:bodyPr>
           <a:lstStyle/>
@@ -16730,7 +16790,7 @@
           <a:noFill/>
         </p:spPr>
         <p:txBody>
-          <a:bodyPr wrap="square" lIns="18288" rIns="18288" tIns="13716" bIns="13716">
+          <a:bodyPr wrap="square" anchor="t" lIns="18288" rIns="18288" tIns="13716" bIns="13716">
             <a:noAutofit/>
           </a:bodyPr>
           <a:lstStyle/>
@@ -16785,7 +16845,7 @@
           <a:noFill/>
         </p:spPr>
         <p:txBody>
-          <a:bodyPr wrap="square" lIns="18288" rIns="18288" tIns="13716" bIns="13716">
+          <a:bodyPr wrap="square" anchor="t" lIns="18288" rIns="18288" tIns="13716" bIns="13716">
             <a:noAutofit/>
           </a:bodyPr>
           <a:lstStyle/>
@@ -16840,7 +16900,7 @@
           <a:noFill/>
         </p:spPr>
         <p:txBody>
-          <a:bodyPr wrap="square" lIns="18288" rIns="18288" tIns="13716" bIns="13716">
+          <a:bodyPr wrap="square" anchor="t" lIns="18288" rIns="18288" tIns="13716" bIns="13716">
             <a:noAutofit/>
           </a:bodyPr>
           <a:lstStyle/>
@@ -16913,7 +16973,7 @@
           <a:noFill/>
         </p:spPr>
         <p:txBody>
-          <a:bodyPr wrap="square" lIns="18288" rIns="18288" tIns="13716" bIns="13716">
+          <a:bodyPr wrap="square" anchor="t" lIns="18288" rIns="18288" tIns="13716" bIns="13716">
             <a:noAutofit/>
           </a:bodyPr>
           <a:lstStyle/>
@@ -16968,7 +17028,7 @@
           <a:noFill/>
         </p:spPr>
         <p:txBody>
-          <a:bodyPr wrap="square" lIns="18288" rIns="18288" tIns="13716" bIns="13716">
+          <a:bodyPr wrap="square" anchor="t" lIns="18288" rIns="18288" tIns="13716" bIns="13716">
             <a:noAutofit/>
           </a:bodyPr>
           <a:lstStyle/>
@@ -17093,7 +17153,7 @@
           <a:noFill/>
         </p:spPr>
         <p:txBody>
-          <a:bodyPr wrap="square" lIns="18288" rIns="18288" tIns="13716" bIns="13716">
+          <a:bodyPr wrap="square" anchor="t" lIns="18288" rIns="18288" tIns="13716" bIns="13716">
             <a:noAutofit/>
           </a:bodyPr>
           <a:lstStyle/>
@@ -17148,7 +17208,7 @@
           <a:noFill/>
         </p:spPr>
         <p:txBody>
-          <a:bodyPr wrap="square" lIns="18288" rIns="18288" tIns="13716" bIns="13716">
+          <a:bodyPr wrap="square" anchor="t" lIns="18288" rIns="18288" tIns="13716" bIns="13716">
             <a:noAutofit/>
           </a:bodyPr>
           <a:lstStyle/>
@@ -17203,7 +17263,7 @@
           <a:noFill/>
         </p:spPr>
         <p:txBody>
-          <a:bodyPr wrap="square" lIns="18288" rIns="18288" tIns="13716" bIns="13716">
+          <a:bodyPr wrap="square" anchor="t" lIns="18288" rIns="18288" tIns="13716" bIns="13716">
             <a:noAutofit/>
           </a:bodyPr>
           <a:lstStyle/>
@@ -17302,7 +17362,7 @@
           <a:noFill/>
         </p:spPr>
         <p:txBody>
-          <a:bodyPr wrap="square" lIns="18288" rIns="18288" tIns="13716" bIns="13716">
+          <a:bodyPr wrap="square" anchor="t" lIns="18288" rIns="18288" tIns="13716" bIns="13716">
             <a:noAutofit/>
           </a:bodyPr>
           <a:lstStyle/>
@@ -17357,7 +17417,7 @@
           <a:noFill/>
         </p:spPr>
         <p:txBody>
-          <a:bodyPr wrap="square" lIns="18288" rIns="18288" tIns="13716" bIns="13716">
+          <a:bodyPr wrap="square" anchor="t" lIns="18288" rIns="18288" tIns="13716" bIns="13716">
             <a:noAutofit/>
           </a:bodyPr>
           <a:lstStyle/>
@@ -17502,7 +17562,7 @@
           <a:noFill/>
         </p:spPr>
         <p:txBody>
-          <a:bodyPr wrap="square" lIns="18288" rIns="18288" tIns="13716" bIns="13716">
+          <a:bodyPr wrap="square" anchor="t" lIns="18288" rIns="18288" tIns="13716" bIns="13716">
             <a:noAutofit/>
           </a:bodyPr>
           <a:lstStyle/>
@@ -17557,7 +17617,7 @@
           <a:noFill/>
         </p:spPr>
         <p:txBody>
-          <a:bodyPr wrap="square" lIns="18288" rIns="18288" tIns="13716" bIns="13716">
+          <a:bodyPr wrap="square" anchor="t" lIns="18288" rIns="18288" tIns="13716" bIns="13716">
             <a:noAutofit/>
           </a:bodyPr>
           <a:lstStyle/>
@@ -17612,7 +17672,7 @@
           <a:noFill/>
         </p:spPr>
         <p:txBody>
-          <a:bodyPr wrap="square" lIns="18288" rIns="18288" tIns="13716" bIns="13716">
+          <a:bodyPr wrap="square" anchor="t" lIns="18288" rIns="18288" tIns="13716" bIns="13716">
             <a:noAutofit/>
           </a:bodyPr>
           <a:lstStyle/>
@@ -17757,7 +17817,7 @@
           <a:noFill/>
         </p:spPr>
         <p:txBody>
-          <a:bodyPr wrap="square" lIns="18288" rIns="18288" tIns="13716" bIns="13716">
+          <a:bodyPr wrap="square" anchor="t" lIns="18288" rIns="18288" tIns="13716" bIns="13716">
             <a:noAutofit/>
           </a:bodyPr>
           <a:lstStyle/>
@@ -17812,7 +17872,7 @@
           <a:noFill/>
         </p:spPr>
         <p:txBody>
-          <a:bodyPr wrap="square" lIns="18288" rIns="18288" tIns="13716" bIns="13716">
+          <a:bodyPr wrap="square" anchor="t" lIns="18288" rIns="18288" tIns="13716" bIns="13716">
             <a:noAutofit/>
           </a:bodyPr>
           <a:lstStyle/>
@@ -17867,7 +17927,7 @@
           <a:noFill/>
         </p:spPr>
         <p:txBody>
-          <a:bodyPr wrap="square" lIns="18288" rIns="18288" tIns="13716" bIns="13716">
+          <a:bodyPr wrap="square" anchor="t" lIns="18288" rIns="18288" tIns="13716" bIns="13716">
             <a:noAutofit/>
           </a:bodyPr>
           <a:lstStyle/>
@@ -18012,7 +18072,7 @@
           <a:noFill/>
         </p:spPr>
         <p:txBody>
-          <a:bodyPr wrap="square" lIns="18288" rIns="18288" tIns="13716" bIns="13716">
+          <a:bodyPr wrap="square" anchor="t" lIns="18288" rIns="18288" tIns="13716" bIns="13716">
             <a:noAutofit/>
           </a:bodyPr>
           <a:lstStyle/>
@@ -18067,7 +18127,7 @@
           <a:noFill/>
         </p:spPr>
         <p:txBody>
-          <a:bodyPr wrap="square" lIns="18288" rIns="18288" tIns="13716" bIns="13716">
+          <a:bodyPr wrap="square" anchor="t" lIns="18288" rIns="18288" tIns="13716" bIns="13716">
             <a:noAutofit/>
           </a:bodyPr>
           <a:lstStyle/>
@@ -18122,7 +18182,7 @@
           <a:noFill/>
         </p:spPr>
         <p:txBody>
-          <a:bodyPr wrap="square" lIns="18288" rIns="18288" tIns="13716" bIns="13716">
+          <a:bodyPr wrap="square" anchor="t" lIns="18288" rIns="18288" tIns="13716" bIns="13716">
             <a:noAutofit/>
           </a:bodyPr>
           <a:lstStyle/>
@@ -18247,7 +18307,7 @@
           <a:noFill/>
         </p:spPr>
         <p:txBody>
-          <a:bodyPr wrap="square" lIns="18288" rIns="18288" tIns="13716" bIns="13716">
+          <a:bodyPr wrap="square" anchor="t" lIns="18288" rIns="18288" tIns="13716" bIns="13716">
             <a:noAutofit/>
           </a:bodyPr>
           <a:lstStyle/>
@@ -18302,7 +18362,7 @@
           <a:noFill/>
         </p:spPr>
         <p:txBody>
-          <a:bodyPr wrap="square" lIns="18288" rIns="18288" tIns="13716" bIns="13716">
+          <a:bodyPr wrap="square" anchor="t" lIns="18288" rIns="18288" tIns="13716" bIns="13716">
             <a:noAutofit/>
           </a:bodyPr>
           <a:lstStyle/>
@@ -18357,7 +18417,7 @@
           <a:noFill/>
         </p:spPr>
         <p:txBody>
-          <a:bodyPr wrap="square" lIns="18288" rIns="18288" tIns="13716" bIns="13716">
+          <a:bodyPr wrap="square" anchor="t" lIns="18288" rIns="18288" tIns="13716" bIns="13716">
             <a:noAutofit/>
           </a:bodyPr>
           <a:lstStyle/>
@@ -18456,7 +18516,7 @@
           <a:noFill/>
         </p:spPr>
         <p:txBody>
-          <a:bodyPr wrap="square" lIns="18288" rIns="18288" tIns="13716" bIns="13716">
+          <a:bodyPr wrap="square" anchor="t" lIns="18288" rIns="18288" tIns="13716" bIns="13716">
             <a:noAutofit/>
           </a:bodyPr>
           <a:lstStyle/>
@@ -18511,7 +18571,7 @@
           <a:noFill/>
         </p:spPr>
         <p:txBody>
-          <a:bodyPr wrap="square" lIns="18288" rIns="18288" tIns="13716" bIns="13716">
+          <a:bodyPr wrap="square" anchor="t" lIns="18288" rIns="18288" tIns="13716" bIns="13716">
             <a:noAutofit/>
           </a:bodyPr>
           <a:lstStyle/>
@@ -18656,7 +18716,7 @@
           <a:noFill/>
         </p:spPr>
         <p:txBody>
-          <a:bodyPr wrap="square" lIns="18288" rIns="18288" tIns="13716" bIns="13716">
+          <a:bodyPr wrap="square" anchor="t" lIns="18288" rIns="18288" tIns="13716" bIns="13716">
             <a:noAutofit/>
           </a:bodyPr>
           <a:lstStyle/>
@@ -18711,7 +18771,7 @@
           <a:noFill/>
         </p:spPr>
         <p:txBody>
-          <a:bodyPr wrap="square" lIns="18288" rIns="18288" tIns="13716" bIns="13716">
+          <a:bodyPr wrap="square" anchor="t" lIns="18288" rIns="18288" tIns="13716" bIns="13716">
             <a:noAutofit/>
           </a:bodyPr>
           <a:lstStyle/>
@@ -18766,7 +18826,7 @@
           <a:noFill/>
         </p:spPr>
         <p:txBody>
-          <a:bodyPr wrap="square" lIns="18288" rIns="18288" tIns="13716" bIns="13716">
+          <a:bodyPr wrap="square" anchor="t" lIns="18288" rIns="18288" tIns="13716" bIns="13716">
             <a:noAutofit/>
           </a:bodyPr>
           <a:lstStyle/>
@@ -18911,7 +18971,7 @@
           <a:noFill/>
         </p:spPr>
         <p:txBody>
-          <a:bodyPr wrap="square" lIns="18288" rIns="18288" tIns="13716" bIns="13716">
+          <a:bodyPr wrap="square" anchor="t" lIns="18288" rIns="18288" tIns="13716" bIns="13716">
             <a:noAutofit/>
           </a:bodyPr>
           <a:lstStyle/>
@@ -18966,7 +19026,7 @@
           <a:noFill/>
         </p:spPr>
         <p:txBody>
-          <a:bodyPr wrap="square" lIns="18288" rIns="18288" tIns="13716" bIns="13716">
+          <a:bodyPr wrap="square" anchor="t" lIns="18288" rIns="18288" tIns="13716" bIns="13716">
             <a:noAutofit/>
           </a:bodyPr>
           <a:lstStyle/>
@@ -19021,7 +19081,7 @@
           <a:noFill/>
         </p:spPr>
         <p:txBody>
-          <a:bodyPr wrap="square" lIns="18288" rIns="18288" tIns="13716" bIns="13716">
+          <a:bodyPr wrap="square" anchor="t" lIns="18288" rIns="18288" tIns="13716" bIns="13716">
             <a:noAutofit/>
           </a:bodyPr>
           <a:lstStyle/>
@@ -19166,7 +19226,7 @@
           <a:noFill/>
         </p:spPr>
         <p:txBody>
-          <a:bodyPr wrap="square" lIns="18288" rIns="18288" tIns="13716" bIns="13716">
+          <a:bodyPr wrap="square" anchor="t" lIns="18288" rIns="18288" tIns="13716" bIns="13716">
             <a:noAutofit/>
           </a:bodyPr>
           <a:lstStyle/>
@@ -19221,7 +19281,7 @@
           <a:noFill/>
         </p:spPr>
         <p:txBody>
-          <a:bodyPr wrap="square" lIns="18288" rIns="18288" tIns="13716" bIns="13716">
+          <a:bodyPr wrap="square" anchor="t" lIns="18288" rIns="18288" tIns="13716" bIns="13716">
             <a:noAutofit/>
           </a:bodyPr>
           <a:lstStyle/>
@@ -19276,7 +19336,7 @@
           <a:noFill/>
         </p:spPr>
         <p:txBody>
-          <a:bodyPr wrap="square" lIns="18288" rIns="18288" tIns="13716" bIns="13716">
+          <a:bodyPr wrap="square" anchor="t" lIns="18288" rIns="18288" tIns="13716" bIns="13716">
             <a:noAutofit/>
           </a:bodyPr>
           <a:lstStyle/>
@@ -19421,7 +19481,7 @@
           <a:noFill/>
         </p:spPr>
         <p:txBody>
-          <a:bodyPr wrap="square" lIns="18288" rIns="18288" tIns="13716" bIns="13716">
+          <a:bodyPr wrap="square" anchor="t" lIns="18288" rIns="18288" tIns="13716" bIns="13716">
             <a:noAutofit/>
           </a:bodyPr>
           <a:lstStyle/>
@@ -19476,7 +19536,7 @@
           <a:noFill/>
         </p:spPr>
         <p:txBody>
-          <a:bodyPr wrap="square" lIns="18288" rIns="18288" tIns="13716" bIns="13716">
+          <a:bodyPr wrap="square" anchor="t" lIns="18288" rIns="18288" tIns="13716" bIns="13716">
             <a:noAutofit/>
           </a:bodyPr>
           <a:lstStyle/>
@@ -19531,7 +19591,7 @@
           <a:noFill/>
         </p:spPr>
         <p:txBody>
-          <a:bodyPr wrap="square" lIns="18288" rIns="18288" tIns="13716" bIns="13716">
+          <a:bodyPr wrap="square" anchor="t" lIns="18288" rIns="18288" tIns="13716" bIns="13716">
             <a:noAutofit/>
           </a:bodyPr>
           <a:lstStyle/>
@@ -19676,7 +19736,7 @@
           <a:noFill/>
         </p:spPr>
         <p:txBody>
-          <a:bodyPr wrap="square" lIns="18288" rIns="18288" tIns="13716" bIns="13716">
+          <a:bodyPr wrap="square" anchor="t" lIns="18288" rIns="18288" tIns="13716" bIns="13716">
             <a:noAutofit/>
           </a:bodyPr>
           <a:lstStyle/>
@@ -19731,7 +19791,7 @@
           <a:noFill/>
         </p:spPr>
         <p:txBody>
-          <a:bodyPr wrap="square" lIns="18288" rIns="18288" tIns="13716" bIns="13716">
+          <a:bodyPr wrap="square" anchor="t" lIns="18288" rIns="18288" tIns="13716" bIns="13716">
             <a:noAutofit/>
           </a:bodyPr>
           <a:lstStyle/>
@@ -19786,7 +19846,7 @@
           <a:noFill/>
         </p:spPr>
         <p:txBody>
-          <a:bodyPr wrap="square" lIns="18288" rIns="18288" tIns="13716" bIns="13716">
+          <a:bodyPr wrap="square" anchor="t" lIns="18288" rIns="18288" tIns="13716" bIns="13716">
             <a:noAutofit/>
           </a:bodyPr>
           <a:lstStyle/>
@@ -19931,7 +19991,7 @@
           <a:noFill/>
         </p:spPr>
         <p:txBody>
-          <a:bodyPr wrap="square" lIns="18288" rIns="18288" tIns="13716" bIns="13716">
+          <a:bodyPr wrap="square" anchor="t" lIns="18288" rIns="18288" tIns="13716" bIns="13716">
             <a:noAutofit/>
           </a:bodyPr>
           <a:lstStyle/>
@@ -19986,7 +20046,7 @@
           <a:noFill/>
         </p:spPr>
         <p:txBody>
-          <a:bodyPr wrap="square" lIns="18288" rIns="18288" tIns="13716" bIns="13716">
+          <a:bodyPr wrap="square" anchor="t" lIns="18288" rIns="18288" tIns="13716" bIns="13716">
             <a:noAutofit/>
           </a:bodyPr>
           <a:lstStyle/>
@@ -20041,7 +20101,7 @@
           <a:noFill/>
         </p:spPr>
         <p:txBody>
-          <a:bodyPr wrap="square" lIns="18288" rIns="18288" tIns="13716" bIns="13716">
+          <a:bodyPr wrap="square" anchor="t" lIns="18288" rIns="18288" tIns="13716" bIns="13716">
             <a:noAutofit/>
           </a:bodyPr>
           <a:lstStyle/>
@@ -20166,7 +20226,7 @@
           <a:noFill/>
         </p:spPr>
         <p:txBody>
-          <a:bodyPr wrap="square" lIns="18288" rIns="18288" tIns="13716" bIns="13716">
+          <a:bodyPr wrap="square" anchor="t" lIns="18288" rIns="18288" tIns="13716" bIns="13716">
             <a:noAutofit/>
           </a:bodyPr>
           <a:lstStyle/>
@@ -20221,7 +20281,7 @@
           <a:noFill/>
         </p:spPr>
         <p:txBody>
-          <a:bodyPr wrap="square" lIns="18288" rIns="18288" tIns="13716" bIns="13716">
+          <a:bodyPr wrap="square" anchor="t" lIns="18288" rIns="18288" tIns="13716" bIns="13716">
             <a:noAutofit/>
           </a:bodyPr>
           <a:lstStyle/>
@@ -20276,7 +20336,7 @@
           <a:noFill/>
         </p:spPr>
         <p:txBody>
-          <a:bodyPr wrap="square" lIns="18288" rIns="18288" tIns="13716" bIns="13716">
+          <a:bodyPr wrap="square" anchor="t" lIns="18288" rIns="18288" tIns="13716" bIns="13716">
             <a:noAutofit/>
           </a:bodyPr>
           <a:lstStyle/>
@@ -20375,7 +20435,7 @@
           <a:noFill/>
         </p:spPr>
         <p:txBody>
-          <a:bodyPr wrap="square" lIns="18288" rIns="18288" tIns="13716" bIns="13716">
+          <a:bodyPr wrap="square" anchor="t" lIns="18288" rIns="18288" tIns="13716" bIns="13716">
             <a:noAutofit/>
           </a:bodyPr>
           <a:lstStyle/>
@@ -20430,7 +20490,7 @@
           <a:noFill/>
         </p:spPr>
         <p:txBody>
-          <a:bodyPr wrap="square" lIns="18288" rIns="18288" tIns="13716" bIns="13716">
+          <a:bodyPr wrap="square" anchor="t" lIns="18288" rIns="18288" tIns="13716" bIns="13716">
             <a:noAutofit/>
           </a:bodyPr>
           <a:lstStyle/>
@@ -20520,8 +20580,8 @@
         </p:nvSpPr>
         <p:spPr>
           <a:xfrm>
-            <a:off x="685800" y="2130552"/>
-            <a:ext cx="2834640" cy="685800"/>
+            <a:off x="685800" y="2139696"/>
+            <a:ext cx="2834640" cy="923544"/>
           </a:xfrm>
           <a:prstGeom prst="rect">
             <a:avLst/>
@@ -20529,7 +20589,7 @@
           <a:noFill/>
         </p:spPr>
         <p:txBody>
-          <a:bodyPr wrap="square" lIns="18288" rIns="18288" tIns="13716" bIns="13716">
+          <a:bodyPr wrap="square" anchor="ctr" lIns="18288" rIns="18288" tIns="13716" bIns="13716">
             <a:noAutofit/>
           </a:bodyPr>
           <a:lstStyle/>
@@ -20575,7 +20635,7 @@
         </p:nvSpPr>
         <p:spPr>
           <a:xfrm>
-            <a:off x="3730752" y="2130552"/>
+            <a:off x="3730752" y="2243455"/>
             <a:ext cx="7790688" cy="331978"/>
           </a:xfrm>
           <a:prstGeom prst="rect">
@@ -20584,7 +20644,7 @@
           <a:noFill/>
         </p:spPr>
         <p:txBody>
-          <a:bodyPr wrap="square" lIns="18288" rIns="18288" tIns="13716" bIns="13716">
+          <a:bodyPr wrap="square" anchor="t" lIns="18288" rIns="18288" tIns="13716" bIns="13716">
             <a:noAutofit/>
           </a:bodyPr>
           <a:lstStyle/>
@@ -20630,7 +20690,7 @@
         </p:nvSpPr>
         <p:spPr>
           <a:xfrm>
-            <a:off x="3730752" y="2553970"/>
+            <a:off x="3730752" y="2666873"/>
             <a:ext cx="7790688" cy="292608"/>
           </a:xfrm>
           <a:prstGeom prst="rect">
@@ -20639,7 +20699,7 @@
           <a:noFill/>
         </p:spPr>
         <p:txBody>
-          <a:bodyPr wrap="square" lIns="18288" rIns="18288" tIns="13716" bIns="13716">
+          <a:bodyPr wrap="square" anchor="t" lIns="18288" rIns="18288" tIns="13716" bIns="13716">
             <a:noAutofit/>
           </a:bodyPr>
           <a:lstStyle/>
@@ -20729,8 +20789,8 @@
         </p:nvSpPr>
         <p:spPr>
           <a:xfrm>
-            <a:off x="685800" y="3108960"/>
-            <a:ext cx="2834640" cy="685800"/>
+            <a:off x="685800" y="3118103"/>
+            <a:ext cx="2834640" cy="923544"/>
           </a:xfrm>
           <a:prstGeom prst="rect">
             <a:avLst/>
@@ -20738,7 +20798,7 @@
           <a:noFill/>
         </p:spPr>
         <p:txBody>
-          <a:bodyPr wrap="square" lIns="18288" rIns="18288" tIns="13716" bIns="13716">
+          <a:bodyPr wrap="square" anchor="ctr" lIns="18288" rIns="18288" tIns="13716" bIns="13716">
             <a:noAutofit/>
           </a:bodyPr>
           <a:lstStyle/>
@@ -20784,7 +20844,7 @@
         </p:nvSpPr>
         <p:spPr>
           <a:xfrm>
-            <a:off x="3730752" y="3108960"/>
+            <a:off x="3730752" y="3221862"/>
             <a:ext cx="7790688" cy="331978"/>
           </a:xfrm>
           <a:prstGeom prst="rect">
@@ -20793,7 +20853,7 @@
           <a:noFill/>
         </p:spPr>
         <p:txBody>
-          <a:bodyPr wrap="square" lIns="18288" rIns="18288" tIns="13716" bIns="13716">
+          <a:bodyPr wrap="square" anchor="t" lIns="18288" rIns="18288" tIns="13716" bIns="13716">
             <a:noAutofit/>
           </a:bodyPr>
           <a:lstStyle/>
@@ -20839,7 +20899,7 @@
         </p:nvSpPr>
         <p:spPr>
           <a:xfrm>
-            <a:off x="3730752" y="3532378"/>
+            <a:off x="3730752" y="3645280"/>
             <a:ext cx="7790688" cy="292608"/>
           </a:xfrm>
           <a:prstGeom prst="rect">
@@ -20848,7 +20908,7 @@
           <a:noFill/>
         </p:spPr>
         <p:txBody>
-          <a:bodyPr wrap="square" lIns="18288" rIns="18288" tIns="13716" bIns="13716">
+          <a:bodyPr wrap="square" anchor="t" lIns="18288" rIns="18288" tIns="13716" bIns="13716">
             <a:noAutofit/>
           </a:bodyPr>
           <a:lstStyle/>
@@ -20938,8 +20998,8 @@
         </p:nvSpPr>
         <p:spPr>
           <a:xfrm>
-            <a:off x="685800" y="4087368"/>
-            <a:ext cx="2834640" cy="685800"/>
+            <a:off x="685800" y="4096512"/>
+            <a:ext cx="2834640" cy="923544"/>
           </a:xfrm>
           <a:prstGeom prst="rect">
             <a:avLst/>
@@ -20947,7 +21007,7 @@
           <a:noFill/>
         </p:spPr>
         <p:txBody>
-          <a:bodyPr wrap="square" lIns="18288" rIns="18288" tIns="13716" bIns="13716">
+          <a:bodyPr wrap="square" anchor="ctr" lIns="18288" rIns="18288" tIns="13716" bIns="13716">
             <a:noAutofit/>
           </a:bodyPr>
           <a:lstStyle/>
@@ -20993,7 +21053,7 @@
         </p:nvSpPr>
         <p:spPr>
           <a:xfrm>
-            <a:off x="3730752" y="4087368"/>
+            <a:off x="3730752" y="4200271"/>
             <a:ext cx="7790688" cy="331978"/>
           </a:xfrm>
           <a:prstGeom prst="rect">
@@ -21002,7 +21062,7 @@
           <a:noFill/>
         </p:spPr>
         <p:txBody>
-          <a:bodyPr wrap="square" lIns="18288" rIns="18288" tIns="13716" bIns="13716">
+          <a:bodyPr wrap="square" anchor="t" lIns="18288" rIns="18288" tIns="13716" bIns="13716">
             <a:noAutofit/>
           </a:bodyPr>
           <a:lstStyle/>
@@ -21048,7 +21108,7 @@
         </p:nvSpPr>
         <p:spPr>
           <a:xfrm>
-            <a:off x="3730752" y="4510786"/>
+            <a:off x="3730752" y="4623689"/>
             <a:ext cx="7790688" cy="292608"/>
           </a:xfrm>
           <a:prstGeom prst="rect">
@@ -21057,7 +21117,7 @@
           <a:noFill/>
         </p:spPr>
         <p:txBody>
-          <a:bodyPr wrap="square" lIns="18288" rIns="18288" tIns="13716" bIns="13716">
+          <a:bodyPr wrap="square" anchor="t" lIns="18288" rIns="18288" tIns="13716" bIns="13716">
             <a:noAutofit/>
           </a:bodyPr>
           <a:lstStyle/>
@@ -21147,8 +21207,8 @@
         </p:nvSpPr>
         <p:spPr>
           <a:xfrm>
-            <a:off x="685800" y="5065775"/>
-            <a:ext cx="2834640" cy="685800"/>
+            <a:off x="685800" y="5074920"/>
+            <a:ext cx="2834640" cy="923544"/>
           </a:xfrm>
           <a:prstGeom prst="rect">
             <a:avLst/>
@@ -21156,7 +21216,7 @@
           <a:noFill/>
         </p:spPr>
         <p:txBody>
-          <a:bodyPr wrap="square" lIns="18288" rIns="18288" tIns="13716" bIns="13716">
+          <a:bodyPr wrap="square" anchor="ctr" lIns="18288" rIns="18288" tIns="13716" bIns="13716">
             <a:noAutofit/>
           </a:bodyPr>
           <a:lstStyle/>
@@ -21202,7 +21262,7 @@
         </p:nvSpPr>
         <p:spPr>
           <a:xfrm>
-            <a:off x="3730752" y="5065775"/>
+            <a:off x="3730752" y="5178679"/>
             <a:ext cx="7790688" cy="331978"/>
           </a:xfrm>
           <a:prstGeom prst="rect">
@@ -21211,7 +21271,7 @@
           <a:noFill/>
         </p:spPr>
         <p:txBody>
-          <a:bodyPr wrap="square" lIns="18288" rIns="18288" tIns="13716" bIns="13716">
+          <a:bodyPr wrap="square" anchor="t" lIns="18288" rIns="18288" tIns="13716" bIns="13716">
             <a:noAutofit/>
           </a:bodyPr>
           <a:lstStyle/>
@@ -21257,7 +21317,7 @@
         </p:nvSpPr>
         <p:spPr>
           <a:xfrm>
-            <a:off x="3730752" y="5489193"/>
+            <a:off x="3730752" y="5602097"/>
             <a:ext cx="7790688" cy="292608"/>
           </a:xfrm>
           <a:prstGeom prst="rect">
@@ -21266,7 +21326,7 @@
           <a:noFill/>
         </p:spPr>
         <p:txBody>
-          <a:bodyPr wrap="square" lIns="18288" rIns="18288" tIns="13716" bIns="13716">
+          <a:bodyPr wrap="square" anchor="t" lIns="18288" rIns="18288" tIns="13716" bIns="13716">
             <a:noAutofit/>
           </a:bodyPr>
           <a:lstStyle/>
@@ -21391,7 +21451,7 @@
           <a:noFill/>
         </p:spPr>
         <p:txBody>
-          <a:bodyPr wrap="square" lIns="18288" rIns="18288" tIns="13716" bIns="13716">
+          <a:bodyPr wrap="square" anchor="t" lIns="18288" rIns="18288" tIns="13716" bIns="13716">
             <a:noAutofit/>
           </a:bodyPr>
           <a:lstStyle/>
@@ -21446,7 +21506,7 @@
           <a:noFill/>
         </p:spPr>
         <p:txBody>
-          <a:bodyPr wrap="square" lIns="18288" rIns="18288" tIns="13716" bIns="13716">
+          <a:bodyPr wrap="square" anchor="t" lIns="18288" rIns="18288" tIns="13716" bIns="13716">
             <a:noAutofit/>
           </a:bodyPr>
           <a:lstStyle/>
@@ -21501,7 +21561,7 @@
           <a:noFill/>
         </p:spPr>
         <p:txBody>
-          <a:bodyPr wrap="square" lIns="18288" rIns="18288" tIns="13716" bIns="13716">
+          <a:bodyPr wrap="square" anchor="t" lIns="18288" rIns="18288" tIns="13716" bIns="13716">
             <a:noAutofit/>
           </a:bodyPr>
           <a:lstStyle/>
@@ -21600,7 +21660,7 @@
           <a:noFill/>
         </p:spPr>
         <p:txBody>
-          <a:bodyPr wrap="square" lIns="18288" rIns="18288" tIns="13716" bIns="13716">
+          <a:bodyPr wrap="square" anchor="t" lIns="18288" rIns="18288" tIns="13716" bIns="13716">
             <a:noAutofit/>
           </a:bodyPr>
           <a:lstStyle/>
@@ -21655,7 +21715,7 @@
           <a:noFill/>
         </p:spPr>
         <p:txBody>
-          <a:bodyPr wrap="square" lIns="18288" rIns="18288" tIns="13716" bIns="13716">
+          <a:bodyPr wrap="square" anchor="t" lIns="18288" rIns="18288" tIns="13716" bIns="13716">
             <a:noAutofit/>
           </a:bodyPr>
           <a:lstStyle/>
@@ -21800,7 +21860,7 @@
           <a:noFill/>
         </p:spPr>
         <p:txBody>
-          <a:bodyPr wrap="square" lIns="18288" rIns="18288" tIns="13716" bIns="13716">
+          <a:bodyPr wrap="square" anchor="t" lIns="18288" rIns="18288" tIns="13716" bIns="13716">
             <a:noAutofit/>
           </a:bodyPr>
           <a:lstStyle/>
@@ -21855,7 +21915,7 @@
           <a:noFill/>
         </p:spPr>
         <p:txBody>
-          <a:bodyPr wrap="square" lIns="18288" rIns="18288" tIns="13716" bIns="13716">
+          <a:bodyPr wrap="square" anchor="t" lIns="18288" rIns="18288" tIns="13716" bIns="13716">
             <a:noAutofit/>
           </a:bodyPr>
           <a:lstStyle/>
@@ -21910,7 +21970,7 @@
           <a:noFill/>
         </p:spPr>
         <p:txBody>
-          <a:bodyPr wrap="square" lIns="18288" rIns="18288" tIns="13716" bIns="13716">
+          <a:bodyPr wrap="square" anchor="t" lIns="18288" rIns="18288" tIns="13716" bIns="13716">
             <a:noAutofit/>
           </a:bodyPr>
           <a:lstStyle/>
@@ -22009,7 +22069,7 @@
           <a:noFill/>
         </p:spPr>
         <p:txBody>
-          <a:bodyPr wrap="square" lIns="18288" rIns="18288" tIns="13716" bIns="13716">
+          <a:bodyPr wrap="square" anchor="t" lIns="18288" rIns="18288" tIns="13716" bIns="13716">
             <a:noAutofit/>
           </a:bodyPr>
           <a:lstStyle/>
@@ -22064,7 +22124,7 @@
           <a:noFill/>
         </p:spPr>
         <p:txBody>
-          <a:bodyPr wrap="square" lIns="18288" rIns="18288" tIns="13716" bIns="13716">
+          <a:bodyPr wrap="square" anchor="t" lIns="18288" rIns="18288" tIns="13716" bIns="13716">
             <a:noAutofit/>
           </a:bodyPr>
           <a:lstStyle/>
@@ -22119,7 +22179,7 @@
           <a:noFill/>
         </p:spPr>
         <p:txBody>
-          <a:bodyPr wrap="square" lIns="18288" rIns="18288" tIns="13716" bIns="13716">
+          <a:bodyPr wrap="square" anchor="t" lIns="18288" rIns="18288" tIns="13716" bIns="13716">
             <a:noAutofit/>
           </a:bodyPr>
           <a:lstStyle/>
@@ -22218,7 +22278,7 @@
           <a:noFill/>
         </p:spPr>
         <p:txBody>
-          <a:bodyPr wrap="square" lIns="18288" rIns="18288" tIns="13716" bIns="13716">
+          <a:bodyPr wrap="square" anchor="t" lIns="18288" rIns="18288" tIns="13716" bIns="13716">
             <a:noAutofit/>
           </a:bodyPr>
           <a:lstStyle/>
@@ -22273,7 +22333,7 @@
           <a:noFill/>
         </p:spPr>
         <p:txBody>
-          <a:bodyPr wrap="square" lIns="18288" rIns="18288" tIns="13716" bIns="13716">
+          <a:bodyPr wrap="square" anchor="t" lIns="18288" rIns="18288" tIns="13716" bIns="13716">
             <a:noAutofit/>
           </a:bodyPr>
           <a:lstStyle/>
@@ -22328,7 +22388,7 @@
           <a:noFill/>
         </p:spPr>
         <p:txBody>
-          <a:bodyPr wrap="square" lIns="18288" rIns="18288" tIns="13716" bIns="13716">
+          <a:bodyPr wrap="square" anchor="t" lIns="18288" rIns="18288" tIns="13716" bIns="13716">
             <a:noAutofit/>
           </a:bodyPr>
           <a:lstStyle/>
@@ -22453,7 +22513,7 @@
           <a:noFill/>
         </p:spPr>
         <p:txBody>
-          <a:bodyPr wrap="square" lIns="18288" rIns="18288" tIns="13716" bIns="13716">
+          <a:bodyPr wrap="square" anchor="t" lIns="18288" rIns="18288" tIns="13716" bIns="13716">
             <a:noAutofit/>
           </a:bodyPr>
           <a:lstStyle/>
@@ -22508,7 +22568,7 @@
           <a:noFill/>
         </p:spPr>
         <p:txBody>
-          <a:bodyPr wrap="square" lIns="18288" rIns="18288" tIns="13716" bIns="13716">
+          <a:bodyPr wrap="square" anchor="t" lIns="18288" rIns="18288" tIns="13716" bIns="13716">
             <a:noAutofit/>
           </a:bodyPr>
           <a:lstStyle/>
@@ -22563,7 +22623,7 @@
           <a:noFill/>
         </p:spPr>
         <p:txBody>
-          <a:bodyPr wrap="square" lIns="18288" rIns="18288" tIns="13716" bIns="13716">
+          <a:bodyPr wrap="square" anchor="t" lIns="18288" rIns="18288" tIns="13716" bIns="13716">
             <a:noAutofit/>
           </a:bodyPr>
           <a:lstStyle/>
@@ -22662,7 +22722,7 @@
           <a:noFill/>
         </p:spPr>
         <p:txBody>
-          <a:bodyPr wrap="square" lIns="18288" rIns="18288" tIns="13716" bIns="13716">
+          <a:bodyPr wrap="square" anchor="t" lIns="18288" rIns="18288" tIns="13716" bIns="13716">
             <a:noAutofit/>
           </a:bodyPr>
           <a:lstStyle/>
@@ -22717,7 +22777,7 @@
           <a:noFill/>
         </p:spPr>
         <p:txBody>
-          <a:bodyPr wrap="square" lIns="18288" rIns="18288" tIns="13716" bIns="13716">
+          <a:bodyPr wrap="square" anchor="t" lIns="18288" rIns="18288" tIns="13716" bIns="13716">
             <a:noAutofit/>
           </a:bodyPr>
           <a:lstStyle/>
@@ -22862,7 +22922,7 @@
           <a:noFill/>
         </p:spPr>
         <p:txBody>
-          <a:bodyPr wrap="square" lIns="18288" rIns="18288" tIns="13716" bIns="13716">
+          <a:bodyPr wrap="square" anchor="t" lIns="18288" rIns="18288" tIns="13716" bIns="13716">
             <a:noAutofit/>
           </a:bodyPr>
           <a:lstStyle/>
@@ -22917,7 +22977,7 @@
           <a:noFill/>
         </p:spPr>
         <p:txBody>
-          <a:bodyPr wrap="square" lIns="18288" rIns="18288" tIns="13716" bIns="13716">
+          <a:bodyPr wrap="square" anchor="t" lIns="18288" rIns="18288" tIns="13716" bIns="13716">
             <a:noAutofit/>
           </a:bodyPr>
           <a:lstStyle/>
@@ -22972,7 +23032,7 @@
           <a:noFill/>
         </p:spPr>
         <p:txBody>
-          <a:bodyPr wrap="square" lIns="18288" rIns="18288" tIns="13716" bIns="13716">
+          <a:bodyPr wrap="square" anchor="t" lIns="18288" rIns="18288" tIns="13716" bIns="13716">
             <a:noAutofit/>
           </a:bodyPr>
           <a:lstStyle/>
@@ -23071,7 +23131,7 @@
           <a:noFill/>
         </p:spPr>
         <p:txBody>
-          <a:bodyPr wrap="square" lIns="18288" rIns="18288" tIns="13716" bIns="13716">
+          <a:bodyPr wrap="square" anchor="t" lIns="18288" rIns="18288" tIns="13716" bIns="13716">
             <a:noAutofit/>
           </a:bodyPr>
           <a:lstStyle/>
@@ -23126,7 +23186,7 @@
           <a:noFill/>
         </p:spPr>
         <p:txBody>
-          <a:bodyPr wrap="square" lIns="18288" rIns="18288" tIns="13716" bIns="13716">
+          <a:bodyPr wrap="square" anchor="t" lIns="18288" rIns="18288" tIns="13716" bIns="13716">
             <a:noAutofit/>
           </a:bodyPr>
           <a:lstStyle/>
@@ -23181,7 +23241,7 @@
           <a:noFill/>
         </p:spPr>
         <p:txBody>
-          <a:bodyPr wrap="square" lIns="18288" rIns="18288" tIns="13716" bIns="13716">
+          <a:bodyPr wrap="square" anchor="t" lIns="18288" rIns="18288" tIns="13716" bIns="13716">
             <a:noAutofit/>
           </a:bodyPr>
           <a:lstStyle/>
@@ -23280,7 +23340,7 @@
           <a:noFill/>
         </p:spPr>
         <p:txBody>
-          <a:bodyPr wrap="square" lIns="18288" rIns="18288" tIns="13716" bIns="13716">
+          <a:bodyPr wrap="square" anchor="t" lIns="18288" rIns="18288" tIns="13716" bIns="13716">
             <a:noAutofit/>
           </a:bodyPr>
           <a:lstStyle/>
@@ -23335,7 +23395,7 @@
           <a:noFill/>
         </p:spPr>
         <p:txBody>
-          <a:bodyPr wrap="square" lIns="18288" rIns="18288" tIns="13716" bIns="13716">
+          <a:bodyPr wrap="square" anchor="t" lIns="18288" rIns="18288" tIns="13716" bIns="13716">
             <a:noAutofit/>
           </a:bodyPr>
           <a:lstStyle/>
@@ -23390,7 +23450,7 @@
           <a:noFill/>
         </p:spPr>
         <p:txBody>
-          <a:bodyPr wrap="square" lIns="18288" rIns="18288" tIns="13716" bIns="13716">
+          <a:bodyPr wrap="square" anchor="t" lIns="18288" rIns="18288" tIns="13716" bIns="13716">
             <a:noAutofit/>
           </a:bodyPr>
           <a:lstStyle/>
@@ -23515,7 +23575,7 @@
           <a:noFill/>
         </p:spPr>
         <p:txBody>
-          <a:bodyPr wrap="square" lIns="18288" rIns="18288" tIns="13716" bIns="13716">
+          <a:bodyPr wrap="square" anchor="t" lIns="18288" rIns="18288" tIns="13716" bIns="13716">
             <a:noAutofit/>
           </a:bodyPr>
           <a:lstStyle/>
@@ -23570,7 +23630,7 @@
           <a:noFill/>
         </p:spPr>
         <p:txBody>
-          <a:bodyPr wrap="square" lIns="18288" rIns="18288" tIns="13716" bIns="13716">
+          <a:bodyPr wrap="square" anchor="t" lIns="18288" rIns="18288" tIns="13716" bIns="13716">
             <a:noAutofit/>
           </a:bodyPr>
           <a:lstStyle/>
@@ -23625,7 +23685,7 @@
           <a:noFill/>
         </p:spPr>
         <p:txBody>
-          <a:bodyPr wrap="square" lIns="18288" rIns="18288" tIns="13716" bIns="13716">
+          <a:bodyPr wrap="square" anchor="t" lIns="18288" rIns="18288" tIns="13716" bIns="13716">
             <a:noAutofit/>
           </a:bodyPr>
           <a:lstStyle/>
@@ -23724,7 +23784,7 @@
           <a:noFill/>
         </p:spPr>
         <p:txBody>
-          <a:bodyPr wrap="square" lIns="18288" rIns="18288" tIns="13716" bIns="13716">
+          <a:bodyPr wrap="square" anchor="t" lIns="18288" rIns="18288" tIns="13716" bIns="13716">
             <a:noAutofit/>
           </a:bodyPr>
           <a:lstStyle/>
@@ -23779,7 +23839,7 @@
           <a:noFill/>
         </p:spPr>
         <p:txBody>
-          <a:bodyPr wrap="square" lIns="18288" rIns="18288" tIns="13716" bIns="13716">
+          <a:bodyPr wrap="square" anchor="t" lIns="18288" rIns="18288" tIns="13716" bIns="13716">
             <a:noAutofit/>
           </a:bodyPr>
           <a:lstStyle/>
@@ -23922,7 +23982,7 @@
           <a:noFill/>
         </p:spPr>
         <p:txBody>
-          <a:bodyPr wrap="square" lIns="18288" rIns="18288" tIns="13716" bIns="13716">
+          <a:bodyPr wrap="square" anchor="t" lIns="18288" rIns="18288" tIns="13716" bIns="13716">
             <a:noAutofit/>
           </a:bodyPr>
           <a:lstStyle/>
@@ -23977,7 +24037,7 @@
           <a:noFill/>
         </p:spPr>
         <p:txBody>
-          <a:bodyPr wrap="square" lIns="18288" rIns="18288" tIns="13716" bIns="13716">
+          <a:bodyPr wrap="square" anchor="t" lIns="18288" rIns="18288" tIns="13716" bIns="13716">
             <a:noAutofit/>
           </a:bodyPr>
           <a:lstStyle/>
@@ -24032,7 +24092,7 @@
           <a:noFill/>
         </p:spPr>
         <p:txBody>
-          <a:bodyPr wrap="square" lIns="18288" rIns="18288" tIns="13716" bIns="13716">
+          <a:bodyPr wrap="square" anchor="t" lIns="18288" rIns="18288" tIns="13716" bIns="13716">
             <a:noAutofit/>
           </a:bodyPr>
           <a:lstStyle/>
@@ -24131,7 +24191,7 @@
           <a:noFill/>
         </p:spPr>
         <p:txBody>
-          <a:bodyPr wrap="square" lIns="18288" rIns="18288" tIns="13716" bIns="13716">
+          <a:bodyPr wrap="square" anchor="t" lIns="18288" rIns="18288" tIns="13716" bIns="13716">
             <a:noAutofit/>
           </a:bodyPr>
           <a:lstStyle/>
@@ -24186,7 +24246,7 @@
           <a:noFill/>
         </p:spPr>
         <p:txBody>
-          <a:bodyPr wrap="square" lIns="18288" rIns="18288" tIns="13716" bIns="13716">
+          <a:bodyPr wrap="square" anchor="t" lIns="18288" rIns="18288" tIns="13716" bIns="13716">
             <a:noAutofit/>
           </a:bodyPr>
           <a:lstStyle/>
@@ -24241,7 +24301,7 @@
           <a:noFill/>
         </p:spPr>
         <p:txBody>
-          <a:bodyPr wrap="square" lIns="18288" rIns="18288" tIns="13716" bIns="13716">
+          <a:bodyPr wrap="square" anchor="t" lIns="18288" rIns="18288" tIns="13716" bIns="13716">
             <a:noAutofit/>
           </a:bodyPr>
           <a:lstStyle/>
@@ -24340,7 +24400,7 @@
           <a:noFill/>
         </p:spPr>
         <p:txBody>
-          <a:bodyPr wrap="square" lIns="18288" rIns="18288" tIns="13716" bIns="13716">
+          <a:bodyPr wrap="square" anchor="t" lIns="18288" rIns="18288" tIns="13716" bIns="13716">
             <a:noAutofit/>
           </a:bodyPr>
           <a:lstStyle/>
@@ -24395,7 +24455,7 @@
           <a:noFill/>
         </p:spPr>
         <p:txBody>
-          <a:bodyPr wrap="square" lIns="18288" rIns="18288" tIns="13716" bIns="13716">
+          <a:bodyPr wrap="square" anchor="t" lIns="18288" rIns="18288" tIns="13716" bIns="13716">
             <a:noAutofit/>
           </a:bodyPr>
           <a:lstStyle/>
@@ -24450,7 +24510,7 @@
           <a:noFill/>
         </p:spPr>
         <p:txBody>
-          <a:bodyPr wrap="square" lIns="18288" rIns="18288" tIns="13716" bIns="13716">
+          <a:bodyPr wrap="square" anchor="t" lIns="18288" rIns="18288" tIns="13716" bIns="13716">
             <a:noAutofit/>
           </a:bodyPr>
           <a:lstStyle/>
@@ -24505,7 +24565,7 @@
           <a:noFill/>
         </p:spPr>
         <p:txBody>
-          <a:bodyPr wrap="square" lIns="18288" rIns="18288" tIns="13716" bIns="13716">
+          <a:bodyPr wrap="square" anchor="t" lIns="18288" rIns="18288" tIns="13716" bIns="13716">
             <a:noAutofit/>
           </a:bodyPr>
           <a:lstStyle/>
@@ -24560,7 +24620,7 @@
           <a:noFill/>
         </p:spPr>
         <p:txBody>
-          <a:bodyPr wrap="square" lIns="18288" rIns="18288" tIns="13716" bIns="13716">
+          <a:bodyPr wrap="square" anchor="t" lIns="18288" rIns="18288" tIns="13716" bIns="13716">
             <a:noAutofit/>
           </a:bodyPr>
           <a:lstStyle/>
@@ -24685,7 +24745,7 @@
           <a:noFill/>
         </p:spPr>
         <p:txBody>
-          <a:bodyPr wrap="square" lIns="18288" rIns="18288" tIns="13716" bIns="13716">
+          <a:bodyPr wrap="square" anchor="t" lIns="18288" rIns="18288" tIns="13716" bIns="13716">
             <a:noAutofit/>
           </a:bodyPr>
           <a:lstStyle/>
@@ -24740,7 +24800,7 @@
           <a:noFill/>
         </p:spPr>
         <p:txBody>
-          <a:bodyPr wrap="square" lIns="18288" rIns="18288" tIns="13716" bIns="13716">
+          <a:bodyPr wrap="square" anchor="t" lIns="18288" rIns="18288" tIns="13716" bIns="13716">
             <a:noAutofit/>
           </a:bodyPr>
           <a:lstStyle/>
@@ -24795,7 +24855,7 @@
           <a:noFill/>
         </p:spPr>
         <p:txBody>
-          <a:bodyPr wrap="square" lIns="18288" rIns="18288" tIns="13716" bIns="13716">
+          <a:bodyPr wrap="square" anchor="t" lIns="18288" rIns="18288" tIns="13716" bIns="13716">
             <a:noAutofit/>
           </a:bodyPr>
           <a:lstStyle/>
@@ -24894,7 +24954,7 @@
           <a:noFill/>
         </p:spPr>
         <p:txBody>
-          <a:bodyPr wrap="square" lIns="18288" rIns="18288" tIns="13716" bIns="13716">
+          <a:bodyPr wrap="square" anchor="t" lIns="18288" rIns="18288" tIns="13716" bIns="13716">
             <a:noAutofit/>
           </a:bodyPr>
           <a:lstStyle/>
@@ -24949,7 +25009,7 @@
           <a:noFill/>
         </p:spPr>
         <p:txBody>
-          <a:bodyPr wrap="square" lIns="18288" rIns="18288" tIns="13716" bIns="13716">
+          <a:bodyPr wrap="square" anchor="t" lIns="18288" rIns="18288" tIns="13716" bIns="13716">
             <a:noAutofit/>
           </a:bodyPr>
           <a:lstStyle/>
@@ -25050,7 +25110,7 @@
           <a:noFill/>
         </p:spPr>
         <p:txBody>
-          <a:bodyPr wrap="square" lIns="18288" rIns="18288" tIns="13716" bIns="13716">
+          <a:bodyPr wrap="square" anchor="t" lIns="18288" rIns="18288" tIns="13716" bIns="13716">
             <a:noAutofit/>
           </a:bodyPr>
           <a:lstStyle/>
@@ -25105,7 +25165,7 @@
           <a:noFill/>
         </p:spPr>
         <p:txBody>
-          <a:bodyPr wrap="square" lIns="18288" rIns="18288" tIns="13716" bIns="13716">
+          <a:bodyPr wrap="square" anchor="t" lIns="18288" rIns="18288" tIns="13716" bIns="13716">
             <a:noAutofit/>
           </a:bodyPr>
           <a:lstStyle/>
@@ -25160,7 +25220,7 @@
           <a:noFill/>
         </p:spPr>
         <p:txBody>
-          <a:bodyPr wrap="square" lIns="18288" rIns="18288" tIns="13716" bIns="13716">
+          <a:bodyPr wrap="square" anchor="t" lIns="18288" rIns="18288" tIns="13716" bIns="13716">
             <a:noAutofit/>
           </a:bodyPr>
           <a:lstStyle/>
@@ -25215,7 +25275,7 @@
           <a:noFill/>
         </p:spPr>
         <p:txBody>
-          <a:bodyPr wrap="square" lIns="18288" rIns="18288" tIns="13716" bIns="13716">
+          <a:bodyPr wrap="square" anchor="t" lIns="18288" rIns="18288" tIns="13716" bIns="13716">
             <a:noAutofit/>
           </a:bodyPr>
           <a:lstStyle/>
@@ -25270,7 +25330,7 @@
           <a:noFill/>
         </p:spPr>
         <p:txBody>
-          <a:bodyPr wrap="square" lIns="18288" rIns="18288" tIns="13716" bIns="13716">
+          <a:bodyPr wrap="square" anchor="t" lIns="18288" rIns="18288" tIns="13716" bIns="13716">
             <a:noAutofit/>
           </a:bodyPr>
           <a:lstStyle/>
@@ -25371,7 +25431,7 @@
           <a:noFill/>
         </p:spPr>
         <p:txBody>
-          <a:bodyPr wrap="square" lIns="18288" rIns="18288" tIns="13716" bIns="13716">
+          <a:bodyPr wrap="square" anchor="t" lIns="18288" rIns="18288" tIns="13716" bIns="13716">
             <a:noAutofit/>
           </a:bodyPr>
           <a:lstStyle/>
@@ -25426,7 +25486,7 @@
           <a:noFill/>
         </p:spPr>
         <p:txBody>
-          <a:bodyPr wrap="square" lIns="18288" rIns="18288" tIns="13716" bIns="13716">
+          <a:bodyPr wrap="square" anchor="t" lIns="18288" rIns="18288" tIns="13716" bIns="13716">
             <a:noAutofit/>
           </a:bodyPr>
           <a:lstStyle/>
@@ -25481,7 +25541,7 @@
           <a:noFill/>
         </p:spPr>
         <p:txBody>
-          <a:bodyPr wrap="square" lIns="18288" rIns="18288" tIns="13716" bIns="13716">
+          <a:bodyPr wrap="square" anchor="t" lIns="18288" rIns="18288" tIns="13716" bIns="13716">
             <a:noAutofit/>
           </a:bodyPr>
           <a:lstStyle/>
@@ -25536,7 +25596,7 @@
           <a:noFill/>
         </p:spPr>
         <p:txBody>
-          <a:bodyPr wrap="square" lIns="18288" rIns="18288" tIns="13716" bIns="13716">
+          <a:bodyPr wrap="square" anchor="t" lIns="18288" rIns="18288" tIns="13716" bIns="13716">
             <a:noAutofit/>
           </a:bodyPr>
           <a:lstStyle/>
@@ -25591,7 +25651,7 @@
           <a:noFill/>
         </p:spPr>
         <p:txBody>
-          <a:bodyPr wrap="square" lIns="18288" rIns="18288" tIns="13716" bIns="13716">
+          <a:bodyPr wrap="square" anchor="t" lIns="18288" rIns="18288" tIns="13716" bIns="13716">
             <a:noAutofit/>
           </a:bodyPr>
           <a:lstStyle/>
@@ -25716,7 +25776,7 @@
           <a:noFill/>
         </p:spPr>
         <p:txBody>
-          <a:bodyPr wrap="square" lIns="18288" rIns="18288" tIns="13716" bIns="13716">
+          <a:bodyPr wrap="square" anchor="t" lIns="18288" rIns="18288" tIns="13716" bIns="13716">
             <a:noAutofit/>
           </a:bodyPr>
           <a:lstStyle/>
@@ -25771,7 +25831,7 @@
           <a:noFill/>
         </p:spPr>
         <p:txBody>
-          <a:bodyPr wrap="square" lIns="18288" rIns="18288" tIns="13716" bIns="13716">
+          <a:bodyPr wrap="square" anchor="t" lIns="18288" rIns="18288" tIns="13716" bIns="13716">
             <a:noAutofit/>
           </a:bodyPr>
           <a:lstStyle/>
@@ -25826,7 +25886,7 @@
           <a:noFill/>
         </p:spPr>
         <p:txBody>
-          <a:bodyPr wrap="square" lIns="18288" rIns="18288" tIns="13716" bIns="13716">
+          <a:bodyPr wrap="square" anchor="t" lIns="18288" rIns="18288" tIns="13716" bIns="13716">
             <a:noAutofit/>
           </a:bodyPr>
           <a:lstStyle/>
@@ -25925,7 +25985,7 @@
           <a:noFill/>
         </p:spPr>
         <p:txBody>
-          <a:bodyPr wrap="square" lIns="18288" rIns="18288" tIns="13716" bIns="13716">
+          <a:bodyPr wrap="square" anchor="t" lIns="18288" rIns="18288" tIns="13716" bIns="13716">
             <a:noAutofit/>
           </a:bodyPr>
           <a:lstStyle/>
@@ -25980,7 +26040,7 @@
           <a:noFill/>
         </p:spPr>
         <p:txBody>
-          <a:bodyPr wrap="square" lIns="18288" rIns="18288" tIns="13716" bIns="13716">
+          <a:bodyPr wrap="square" anchor="t" lIns="18288" rIns="18288" tIns="13716" bIns="13716">
             <a:noAutofit/>
           </a:bodyPr>
           <a:lstStyle/>
@@ -26035,7 +26095,7 @@
           <a:noFill/>
         </p:spPr>
         <p:txBody>
-          <a:bodyPr wrap="square" lIns="18288" rIns="18288" tIns="13716" bIns="13716">
+          <a:bodyPr wrap="square" anchor="t" lIns="18288" rIns="18288" tIns="13716" bIns="13716">
             <a:noAutofit/>
           </a:bodyPr>
           <a:lstStyle/>
@@ -26134,7 +26194,7 @@
           <a:noFill/>
         </p:spPr>
         <p:txBody>
-          <a:bodyPr wrap="square" lIns="18288" rIns="18288" tIns="13716" bIns="13716">
+          <a:bodyPr wrap="square" anchor="t" lIns="18288" rIns="18288" tIns="13716" bIns="13716">
             <a:noAutofit/>
           </a:bodyPr>
           <a:lstStyle/>
@@ -26189,7 +26249,7 @@
           <a:noFill/>
         </p:spPr>
         <p:txBody>
-          <a:bodyPr wrap="square" lIns="18288" rIns="18288" tIns="13716" bIns="13716">
+          <a:bodyPr wrap="square" anchor="t" lIns="18288" rIns="18288" tIns="13716" bIns="13716">
             <a:noAutofit/>
           </a:bodyPr>
           <a:lstStyle/>
@@ -26244,7 +26304,7 @@
           <a:noFill/>
         </p:spPr>
         <p:txBody>
-          <a:bodyPr wrap="square" lIns="18288" rIns="18288" tIns="13716" bIns="13716">
+          <a:bodyPr wrap="square" anchor="t" lIns="18288" rIns="18288" tIns="13716" bIns="13716">
             <a:noAutofit/>
           </a:bodyPr>
           <a:lstStyle/>
@@ -26343,7 +26403,7 @@
           <a:noFill/>
         </p:spPr>
         <p:txBody>
-          <a:bodyPr wrap="square" lIns="18288" rIns="18288" tIns="13716" bIns="13716">
+          <a:bodyPr wrap="square" anchor="t" lIns="18288" rIns="18288" tIns="13716" bIns="13716">
             <a:noAutofit/>
           </a:bodyPr>
           <a:lstStyle/>
@@ -26398,7 +26458,7 @@
           <a:noFill/>
         </p:spPr>
         <p:txBody>
-          <a:bodyPr wrap="square" lIns="18288" rIns="18288" tIns="13716" bIns="13716">
+          <a:bodyPr wrap="square" anchor="t" lIns="18288" rIns="18288" tIns="13716" bIns="13716">
             <a:noAutofit/>
           </a:bodyPr>
           <a:lstStyle/>
@@ -26453,7 +26513,7 @@
           <a:noFill/>
         </p:spPr>
         <p:txBody>
-          <a:bodyPr wrap="square" lIns="18288" rIns="18288" tIns="13716" bIns="13716">
+          <a:bodyPr wrap="square" anchor="t" lIns="18288" rIns="18288" tIns="13716" bIns="13716">
             <a:noAutofit/>
           </a:bodyPr>
           <a:lstStyle/>
@@ -26552,7 +26612,7 @@
           <a:noFill/>
         </p:spPr>
         <p:txBody>
-          <a:bodyPr wrap="square" lIns="18288" rIns="18288" tIns="13716" bIns="13716">
+          <a:bodyPr wrap="square" anchor="t" lIns="18288" rIns="18288" tIns="13716" bIns="13716">
             <a:noAutofit/>
           </a:bodyPr>
           <a:lstStyle/>
@@ -26607,7 +26667,7 @@
           <a:noFill/>
         </p:spPr>
         <p:txBody>
-          <a:bodyPr wrap="square" lIns="18288" rIns="18288" tIns="13716" bIns="13716">
+          <a:bodyPr wrap="square" anchor="t" lIns="18288" rIns="18288" tIns="13716" bIns="13716">
             <a:noAutofit/>
           </a:bodyPr>
           <a:lstStyle/>

</xml_diff>